<commit_message>
Drop the decorative network graphic from the title slide
Replaced decor_network.png (scattered blue dots, distracting) with a
plain orange accent bar beside the title. decor_network.png is now
unused.

Co-Authored-By: Claude Sonnet 5 <noreply@anthropic.com>
</commit_message>
<xml_diff>
--- a/slides/Presentation1.pptx
+++ b/slides/Presentation1.pptx
@@ -3143,30 +3143,63 @@
           </a:p>
         </p:txBody>
       </p:sp>
-      <p:pic>
-        <p:nvPicPr>
-          <p:cNvPr id="3" name="Picture 2" descr="decor_network.png"/>
-          <p:cNvPicPr>
-            <a:picLocks noChangeAspect="1"/>
-          </p:cNvPicPr>
-          <p:nvPr/>
-        </p:nvPicPr>
-        <p:blipFill>
-          <a:blip r:embed="rId2"/>
-          <a:stretch>
-            <a:fillRect/>
-          </a:stretch>
-        </p:blipFill>
-        <p:spPr>
-          <a:xfrm>
-            <a:off x="8275320" y="320040"/>
-            <a:ext cx="3657600" cy="3657600"/>
-          </a:xfrm>
-          <a:prstGeom prst="rect">
-            <a:avLst/>
-          </a:prstGeom>
-        </p:spPr>
-      </p:pic>
+      <p:sp>
+        <p:nvSpPr>
+          <p:cNvPr id="3" name="Rounded Rectangle 2"/>
+          <p:cNvSpPr/>
+          <p:nvPr/>
+        </p:nvSpPr>
+        <p:spPr>
+          <a:xfrm>
+            <a:off x="822960" y="2514600"/>
+            <a:ext cx="502920" cy="1554480"/>
+          </a:xfrm>
+          <a:prstGeom prst="roundRect">
+            <a:avLst>
+              <a:gd name="adj" fmla="val 12000"/>
+            </a:avLst>
+          </a:prstGeom>
+          <a:solidFill>
+            <a:srgbClr val="EB6834"/>
+          </a:solidFill>
+          <a:ln w="15875">
+            <a:solidFill>
+              <a:srgbClr val="EB6834"/>
+            </a:solidFill>
+          </a:ln>
+          <a:effectLst/>
+        </p:spPr>
+        <p:style>
+          <a:lnRef idx="1">
+            <a:schemeClr val="accent1"/>
+          </a:lnRef>
+          <a:fillRef idx="3">
+            <a:schemeClr val="accent1"/>
+          </a:fillRef>
+          <a:effectRef idx="2">
+            <a:schemeClr val="accent1"/>
+          </a:effectRef>
+          <a:fontRef idx="minor">
+            <a:schemeClr val="lt1"/>
+          </a:fontRef>
+        </p:style>
+        <p:txBody>
+          <a:bodyPr rtlCol="0" anchor="ctr" wrap="square" lIns="109728" rIns="109728"/>
+          <a:lstStyle/>
+          <a:p>
+            <a:pPr algn="ctr"/>
+            <a:r>
+              <a:rPr sz="1400" b="0">
+                <a:solidFill>
+                  <a:srgbClr val="19180F"/>
+                </a:solidFill>
+                <a:latin typeface="Calibri"/>
+              </a:rPr>
+              <a:t/>
+            </a:r>
+          </a:p>
+        </p:txBody>
+      </p:sp>
       <p:sp>
         <p:nvSpPr>
           <p:cNvPr id="4" name="TextBox 3"/>
@@ -3175,8 +3208,8 @@
         </p:nvSpPr>
         <p:spPr>
           <a:xfrm>
-            <a:off x="822960" y="1874519"/>
-            <a:ext cx="10515600" cy="457200"/>
+            <a:off x="1600200" y="1965960"/>
+            <a:ext cx="10058400" cy="457200"/>
           </a:xfrm>
           <a:prstGeom prst="rect">
             <a:avLst/>
@@ -3214,8 +3247,8 @@
         </p:nvSpPr>
         <p:spPr>
           <a:xfrm>
-            <a:off x="822960" y="2423160"/>
-            <a:ext cx="10515600" cy="1737360"/>
+            <a:off x="1600200" y="2514600"/>
+            <a:ext cx="10058400" cy="1737360"/>
           </a:xfrm>
           <a:prstGeom prst="rect">
             <a:avLst/>
@@ -3269,8 +3302,8 @@
         </p:nvSpPr>
         <p:spPr>
           <a:xfrm>
-            <a:off x="822960" y="4343400"/>
-            <a:ext cx="10424160" cy="914400"/>
+            <a:off x="1600200" y="4434840"/>
+            <a:ext cx="9692640" cy="914400"/>
           </a:xfrm>
           <a:prstGeom prst="rect">
             <a:avLst/>
@@ -3324,7 +3357,7 @@
         </p:nvSpPr>
         <p:spPr>
           <a:xfrm>
-            <a:off x="822960" y="5989320"/>
+            <a:off x="1600200" y="5989320"/>
             <a:ext cx="8229600" cy="457200"/>
           </a:xfrm>
           <a:prstGeom prst="rect">

</xml_diff>

<commit_message>
Restore the title-slide network graphic
Reverts the previous commit's removal -- the decorative network image
stays on the title slide.

Co-Authored-By: Claude Sonnet 5 <noreply@anthropic.com>
</commit_message>
<xml_diff>
--- a/slides/Presentation1.pptx
+++ b/slides/Presentation1.pptx
@@ -3143,63 +3143,30 @@
           </a:p>
         </p:txBody>
       </p:sp>
-      <p:sp>
-        <p:nvSpPr>
-          <p:cNvPr id="3" name="Rounded Rectangle 2"/>
-          <p:cNvSpPr/>
-          <p:nvPr/>
-        </p:nvSpPr>
-        <p:spPr>
-          <a:xfrm>
-            <a:off x="822960" y="2514600"/>
-            <a:ext cx="502920" cy="1554480"/>
-          </a:xfrm>
-          <a:prstGeom prst="roundRect">
-            <a:avLst>
-              <a:gd name="adj" fmla="val 12000"/>
-            </a:avLst>
-          </a:prstGeom>
-          <a:solidFill>
-            <a:srgbClr val="EB6834"/>
-          </a:solidFill>
-          <a:ln w="15875">
-            <a:solidFill>
-              <a:srgbClr val="EB6834"/>
-            </a:solidFill>
-          </a:ln>
-          <a:effectLst/>
-        </p:spPr>
-        <p:style>
-          <a:lnRef idx="1">
-            <a:schemeClr val="accent1"/>
-          </a:lnRef>
-          <a:fillRef idx="3">
-            <a:schemeClr val="accent1"/>
-          </a:fillRef>
-          <a:effectRef idx="2">
-            <a:schemeClr val="accent1"/>
-          </a:effectRef>
-          <a:fontRef idx="minor">
-            <a:schemeClr val="lt1"/>
-          </a:fontRef>
-        </p:style>
-        <p:txBody>
-          <a:bodyPr rtlCol="0" anchor="ctr" wrap="square" lIns="109728" rIns="109728"/>
-          <a:lstStyle/>
-          <a:p>
-            <a:pPr algn="ctr"/>
-            <a:r>
-              <a:rPr sz="1400" b="0">
-                <a:solidFill>
-                  <a:srgbClr val="19180F"/>
-                </a:solidFill>
-                <a:latin typeface="Calibri"/>
-              </a:rPr>
-              <a:t/>
-            </a:r>
-          </a:p>
-        </p:txBody>
-      </p:sp>
+      <p:pic>
+        <p:nvPicPr>
+          <p:cNvPr id="3" name="Picture 2" descr="decor_network.png"/>
+          <p:cNvPicPr>
+            <a:picLocks noChangeAspect="1"/>
+          </p:cNvPicPr>
+          <p:nvPr/>
+        </p:nvPicPr>
+        <p:blipFill>
+          <a:blip r:embed="rId2"/>
+          <a:stretch>
+            <a:fillRect/>
+          </a:stretch>
+        </p:blipFill>
+        <p:spPr>
+          <a:xfrm>
+            <a:off x="8275320" y="320040"/>
+            <a:ext cx="3657600" cy="3657600"/>
+          </a:xfrm>
+          <a:prstGeom prst="rect">
+            <a:avLst/>
+          </a:prstGeom>
+        </p:spPr>
+      </p:pic>
       <p:sp>
         <p:nvSpPr>
           <p:cNvPr id="4" name="TextBox 3"/>
@@ -3208,8 +3175,8 @@
         </p:nvSpPr>
         <p:spPr>
           <a:xfrm>
-            <a:off x="1600200" y="1965960"/>
-            <a:ext cx="10058400" cy="457200"/>
+            <a:off x="822960" y="1874519"/>
+            <a:ext cx="10515600" cy="457200"/>
           </a:xfrm>
           <a:prstGeom prst="rect">
             <a:avLst/>
@@ -3247,8 +3214,8 @@
         </p:nvSpPr>
         <p:spPr>
           <a:xfrm>
-            <a:off x="1600200" y="2514600"/>
-            <a:ext cx="10058400" cy="1737360"/>
+            <a:off x="822960" y="2423160"/>
+            <a:ext cx="10515600" cy="1737360"/>
           </a:xfrm>
           <a:prstGeom prst="rect">
             <a:avLst/>
@@ -3302,8 +3269,8 @@
         </p:nvSpPr>
         <p:spPr>
           <a:xfrm>
-            <a:off x="1600200" y="4434840"/>
-            <a:ext cx="9692640" cy="914400"/>
+            <a:off x="822960" y="4343400"/>
+            <a:ext cx="10424160" cy="914400"/>
           </a:xfrm>
           <a:prstGeom prst="rect">
             <a:avLst/>
@@ -3357,7 +3324,7 @@
         </p:nvSpPr>
         <p:spPr>
           <a:xfrm>
-            <a:off x="1600200" y="5989320"/>
+            <a:off x="822960" y="5989320"/>
             <a:ext cx="8229600" cy="457200"/>
           </a:xfrm>
           <a:prstGeom prst="rect">

</xml_diff>